<commit_message>
docs: dashboard screenshots in the README and on the demo slide
Four screenshots of the live dashboard (home, claim explorer, integrity audit, system transparency) running on the rebuilt demo database. The README gains a dashboard gallery and a quick-start step for the two rebuild scripts; slide 12 now pairs each demo step with its screenshot as a fallback, and slide 4 states that its counts describe the full audited corpus.

Co-Authored-By: Claude Opus 5 <noreply@anthropic.com>
</commit_message>
<xml_diff>
--- a/docs/presentation/ESGenuine_presentation.pptx
+++ b/docs/presentation/ESGenuine_presentation.pptx
@@ -730,7 +730,13 @@
           <a:lstStyle/>
           <a:p>
             <a:r>
-              <a:t>Demo path, about 3 minutes. Have the dashboard already open and loaded before this slide — the globe takes a few seconds on first load. Backup: keep a screenshot of each step open in another window in case the venue network fails.</a:t>
+              <a:t>Demo path, about 3 minutes. Have the dashboard already open and loaded before this slide — the globe takes a few seconds on first load. Use 'Jump to company' on the globe rather than dragging it. The screenshots on this slide are the backup if the venue network fails: talk through them in the same order.</a:t>
+            </a:r>
+          </a:p>
+          <a:p/>
+          <a:p>
+            <a:r>
+              <a:t>The demo database holds three reports (Tata Power BRSR FY24, Shell 2022 and 2023; 1,556 claims). Stay on the four pages shown here: Benchmark and Portfolio Overview surface raw extracted locations and mixed-unit series that are not yet cleaned.</a:t>
             </a:r>
           </a:p>
         </p:txBody>
@@ -1011,6 +1017,12 @@
           <a:p>
             <a:r>
               <a:t>This is not a scaffold — it has been run end to end. 1,730 claims from six reports, 461 pages, four companies. The NLI contradiction step and the Sentinel-2 satellite checks have both genuinely executed and persisted results.</a:t>
+            </a:r>
+          </a:p>
+          <a:p/>
+          <a:p>
+            <a:r>
+              <a:t>If asked why the live demo shows fewer claims: the demo database is a rebuild of three of these reports (Tata Power BRSR FY24, Shell 2022 and 2023 — 1,556 claims) loaded from the extractions committed to the repository, with the same repair layer applied. Infosys and Microsoft would need the LLM to be re-run.</a:t>
             </a:r>
           </a:p>
         </p:txBody>
@@ -5421,7 +5433,7 @@
                 </a:solidFill>
                 <a:latin typeface="Segoe UI"/>
               </a:rPr>
-              <a:t>One claim, from the globe down to its source sentence</a:t>
+              <a:t>One claim, from the dashboard down to its source sentence</a:t>
             </a:r>
           </a:p>
         </p:txBody>
@@ -5503,8 +5515,8 @@
         </p:nvSpPr>
         <p:spPr>
           <a:xfrm>
-            <a:off x="548640" y="1874519"/>
-            <a:ext cx="566928" cy="566928"/>
+            <a:off x="548640" y="1783080"/>
+            <a:ext cx="457200" cy="457200"/>
           </a:xfrm>
           <a:prstGeom prst="ellipse">
             <a:avLst/>
@@ -5532,12 +5544,12 @@
           </a:fontRef>
         </p:style>
         <p:txBody>
-          <a:bodyPr rtlCol="0" anchor="ctr"/>
+          <a:bodyPr rtlCol="0" anchor="ctr" lIns="0" rIns="0"/>
           <a:lstStyle/>
           <a:p>
             <a:pPr algn="ctr"/>
             <a:r>
-              <a:rPr sz="1700" b="0" i="0">
+              <a:rPr sz="1400" b="0" i="0">
                 <a:solidFill>
                   <a:srgbClr val="FFFFFF"/>
                 </a:solidFill>
@@ -5556,8 +5568,8 @@
         </p:nvSpPr>
         <p:spPr>
           <a:xfrm>
-            <a:off x="1417320" y="1856231"/>
-            <a:ext cx="10058400" cy="685800"/>
+            <a:off x="1207008" y="1746504"/>
+            <a:ext cx="3566160" cy="914400"/>
           </a:xfrm>
           <a:prstGeom prst="rect">
             <a:avLst/>
@@ -5571,22 +5583,29 @@
           <a:lstStyle/>
           <a:p>
             <a:r>
-              <a:rPr sz="1900" b="0" i="0">
+              <a:rPr sz="1700" b="0" i="0">
                 <a:solidFill>
                   <a:srgbClr val="0B0B0B"/>
                 </a:solidFill>
                 <a:latin typeface="Segoe UI Semibold"/>
               </a:rPr>
-              <a:t>Portfolio globe</a:t>
-            </a:r>
-            <a:r>
-              <a:rPr sz="1600" b="0" i="0">
+              <a:t>Live dashboard</a:t>
+            </a:r>
+          </a:p>
+          <a:p>
+            <a:pPr>
+              <a:spcBef>
+                <a:spcPts val="200"/>
+              </a:spcBef>
+            </a:pPr>
+            <a:r>
+              <a:rPr sz="1300" b="0" i="0">
                 <a:solidFill>
                   <a:srgbClr val="52514E"/>
                 </a:solidFill>
                 <a:latin typeface="Segoe UI"/>
               </a:rPr>
-              <a:t>   pick a company from the map</a:t>
+              <a:t>claims at a glance; jump to a company on the globe</a:t>
             </a:r>
           </a:p>
         </p:txBody>
@@ -5599,8 +5618,8 @@
         </p:nvSpPr>
         <p:spPr>
           <a:xfrm>
-            <a:off x="548640" y="2807207"/>
-            <a:ext cx="566928" cy="566928"/>
+            <a:off x="548640" y="2807208"/>
+            <a:ext cx="457200" cy="457200"/>
           </a:xfrm>
           <a:prstGeom prst="ellipse">
             <a:avLst/>
@@ -5628,12 +5647,12 @@
           </a:fontRef>
         </p:style>
         <p:txBody>
-          <a:bodyPr rtlCol="0" anchor="ctr"/>
+          <a:bodyPr rtlCol="0" anchor="ctr" lIns="0" rIns="0"/>
           <a:lstStyle/>
           <a:p>
             <a:pPr algn="ctr"/>
             <a:r>
-              <a:rPr sz="1700" b="0" i="0">
+              <a:rPr sz="1400" b="0" i="0">
                 <a:solidFill>
                   <a:srgbClr val="FFFFFF"/>
                 </a:solidFill>
@@ -5652,8 +5671,8 @@
         </p:nvSpPr>
         <p:spPr>
           <a:xfrm>
-            <a:off x="1417320" y="2788919"/>
-            <a:ext cx="10058400" cy="685800"/>
+            <a:off x="1207008" y="2770632"/>
+            <a:ext cx="3566160" cy="914400"/>
           </a:xfrm>
           <a:prstGeom prst="rect">
             <a:avLst/>
@@ -5667,7 +5686,7 @@
           <a:lstStyle/>
           <a:p>
             <a:r>
-              <a:rPr sz="1900" b="0" i="0">
+              <a:rPr sz="1700" b="0" i="0">
                 <a:solidFill>
                   <a:srgbClr val="0B0B0B"/>
                 </a:solidFill>
@@ -5675,14 +5694,21 @@
               </a:rPr>
               <a:t>Claim explorer</a:t>
             </a:r>
-            <a:r>
-              <a:rPr sz="1600" b="0" i="0">
+          </a:p>
+          <a:p>
+            <a:pPr>
+              <a:spcBef>
+                <a:spcPts val="200"/>
+              </a:spcBef>
+            </a:pPr>
+            <a:r>
+              <a:rPr sz="1300" b="0" i="0">
                 <a:solidFill>
                   <a:srgbClr val="52514E"/>
                 </a:solidFill>
                 <a:latin typeface="Segoe UI"/>
               </a:rPr>
-              <a:t>   open a claim: value, unit, taxonomy node, page, source sentence</a:t>
+              <a:t>company → report → claim, each with page and source sentence</a:t>
             </a:r>
           </a:p>
         </p:txBody>
@@ -5695,8 +5721,8 @@
         </p:nvSpPr>
         <p:spPr>
           <a:xfrm>
-            <a:off x="548640" y="3739895"/>
-            <a:ext cx="566928" cy="566928"/>
+            <a:off x="548640" y="3831336"/>
+            <a:ext cx="457200" cy="457200"/>
           </a:xfrm>
           <a:prstGeom prst="ellipse">
             <a:avLst/>
@@ -5724,12 +5750,12 @@
           </a:fontRef>
         </p:style>
         <p:txBody>
-          <a:bodyPr rtlCol="0" anchor="ctr"/>
+          <a:bodyPr rtlCol="0" anchor="ctr" lIns="0" rIns="0"/>
           <a:lstStyle/>
           <a:p>
             <a:pPr algn="ctr"/>
             <a:r>
-              <a:rPr sz="1700" b="0" i="0">
+              <a:rPr sz="1400" b="0" i="0">
                 <a:solidFill>
                   <a:srgbClr val="FFFFFF"/>
                 </a:solidFill>
@@ -5748,8 +5774,8 @@
         </p:nvSpPr>
         <p:spPr>
           <a:xfrm>
-            <a:off x="1417320" y="3721607"/>
-            <a:ext cx="10058400" cy="685800"/>
+            <a:off x="1207008" y="3794760"/>
+            <a:ext cx="3566160" cy="914400"/>
           </a:xfrm>
           <a:prstGeom prst="rect">
             <a:avLst/>
@@ -5763,7 +5789,7 @@
           <a:lstStyle/>
           <a:p>
             <a:r>
-              <a:rPr sz="1900" b="0" i="0">
+              <a:rPr sz="1700" b="0" i="0">
                 <a:solidFill>
                   <a:srgbClr val="0B0B0B"/>
                 </a:solidFill>
@@ -5771,14 +5797,21 @@
               </a:rPr>
               <a:t>Integrity audit</a:t>
             </a:r>
-            <a:r>
-              <a:rPr sz="1600" b="0" i="0">
+          </a:p>
+          <a:p>
+            <a:pPr>
+              <a:spcBef>
+                <a:spcPts val="200"/>
+              </a:spcBef>
+            </a:pPr>
+            <a:r>
+              <a:rPr sz="1300" b="0" i="0">
                 <a:solidFill>
                   <a:srgbClr val="52514E"/>
                 </a:solidFill>
                 <a:latin typeface="Segoe UI"/>
               </a:rPr>
-              <a:t>   greenwashing flags and cross-report contradictions</a:t>
+              <a:t>score, greenwashing flags, contradictions, fact-check</a:t>
             </a:r>
           </a:p>
         </p:txBody>
@@ -5791,8 +5824,8 @@
         </p:nvSpPr>
         <p:spPr>
           <a:xfrm>
-            <a:off x="548640" y="4672583"/>
-            <a:ext cx="566928" cy="566928"/>
+            <a:off x="548640" y="4855464"/>
+            <a:ext cx="457200" cy="457200"/>
           </a:xfrm>
           <a:prstGeom prst="ellipse">
             <a:avLst/>
@@ -5820,12 +5853,12 @@
           </a:fontRef>
         </p:style>
         <p:txBody>
-          <a:bodyPr rtlCol="0" anchor="ctr"/>
+          <a:bodyPr rtlCol="0" anchor="ctr" lIns="0" rIns="0"/>
           <a:lstStyle/>
           <a:p>
             <a:pPr algn="ctr"/>
             <a:r>
-              <a:rPr sz="1700" b="0" i="0">
+              <a:rPr sz="1400" b="0" i="0">
                 <a:solidFill>
                   <a:srgbClr val="FFFFFF"/>
                 </a:solidFill>
@@ -5844,8 +5877,8 @@
         </p:nvSpPr>
         <p:spPr>
           <a:xfrm>
-            <a:off x="1417320" y="4654295"/>
-            <a:ext cx="10058400" cy="685800"/>
+            <a:off x="1207008" y="4818888"/>
+            <a:ext cx="3566160" cy="914400"/>
           </a:xfrm>
           <a:prstGeom prst="rect">
             <a:avLst/>
@@ -5859,7 +5892,7 @@
           <a:lstStyle/>
           <a:p>
             <a:r>
-              <a:rPr sz="1900" b="0" i="0">
+              <a:rPr sz="1700" b="0" i="0">
                 <a:solidFill>
                   <a:srgbClr val="0B0B0B"/>
                 </a:solidFill>
@@ -5867,14 +5900,349 @@
               </a:rPr>
               <a:t>System transparency</a:t>
             </a:r>
-            <a:r>
-              <a:rPr sz="1600" b="0" i="0">
+          </a:p>
+          <a:p>
+            <a:pPr>
+              <a:spcBef>
+                <a:spcPts val="200"/>
+              </a:spcBef>
+            </a:pPr>
+            <a:r>
+              <a:rPr sz="1300" b="0" i="0">
                 <a:solidFill>
                   <a:srgbClr val="52514E"/>
                 </a:solidFill>
                 <a:latin typeface="Segoe UI"/>
               </a:rPr>
-              <a:t>   the pipeline and models behind every number</a:t>
+              <a:t>the pipeline and models behind every number</a:t>
+            </a:r>
+          </a:p>
+        </p:txBody>
+      </p:sp>
+      <p:pic>
+        <p:nvPicPr>
+          <p:cNvPr id="14" name="Picture 13" descr="1-home-globe.png"/>
+          <p:cNvPicPr>
+            <a:picLocks noChangeAspect="1"/>
+          </p:cNvPicPr>
+          <p:nvPr/>
+        </p:nvPicPr>
+        <p:blipFill>
+          <a:blip r:embed="rId2"/>
+          <a:stretch>
+            <a:fillRect/>
+          </a:stretch>
+        </p:blipFill>
+        <p:spPr>
+          <a:xfrm>
+            <a:off x="5074920" y="1737360"/>
+            <a:ext cx="3200400" cy="2000250"/>
+          </a:xfrm>
+          <a:prstGeom prst="rect">
+            <a:avLst/>
+          </a:prstGeom>
+          <a:ln w="9525">
+            <a:solidFill>
+              <a:srgbClr val="C3C2B7"/>
+            </a:solidFill>
+          </a:ln>
+        </p:spPr>
+      </p:pic>
+      <p:sp>
+        <p:nvSpPr>
+          <p:cNvPr id="15" name="Oval 14"/>
+          <p:cNvSpPr/>
+          <p:nvPr/>
+        </p:nvSpPr>
+        <p:spPr>
+          <a:xfrm>
+            <a:off x="5148072" y="1810512"/>
+            <a:ext cx="292608" cy="292608"/>
+          </a:xfrm>
+          <a:prstGeom prst="ellipse">
+            <a:avLst/>
+          </a:prstGeom>
+          <a:solidFill>
+            <a:srgbClr val="2A78D6"/>
+          </a:solidFill>
+          <a:ln>
+            <a:noFill/>
+          </a:ln>
+          <a:effectLst/>
+        </p:spPr>
+        <p:style>
+          <a:lnRef idx="1">
+            <a:schemeClr val="accent1"/>
+          </a:lnRef>
+          <a:fillRef idx="3">
+            <a:schemeClr val="accent1"/>
+          </a:fillRef>
+          <a:effectRef idx="2">
+            <a:schemeClr val="accent1"/>
+          </a:effectRef>
+          <a:fontRef idx="minor">
+            <a:schemeClr val="lt1"/>
+          </a:fontRef>
+        </p:style>
+        <p:txBody>
+          <a:bodyPr rtlCol="0" anchor="ctr" lIns="0" rIns="0"/>
+          <a:lstStyle/>
+          <a:p>
+            <a:pPr algn="ctr"/>
+            <a:r>
+              <a:rPr sz="1000" b="0" i="0">
+                <a:solidFill>
+                  <a:srgbClr val="FFFFFF"/>
+                </a:solidFill>
+                <a:latin typeface="Segoe UI Semibold"/>
+              </a:rPr>
+              <a:t>1</a:t>
+            </a:r>
+          </a:p>
+        </p:txBody>
+      </p:sp>
+      <p:pic>
+        <p:nvPicPr>
+          <p:cNvPr id="16" name="Picture 15" descr="2-claim-explorer.png"/>
+          <p:cNvPicPr>
+            <a:picLocks noChangeAspect="1"/>
+          </p:cNvPicPr>
+          <p:nvPr/>
+        </p:nvPicPr>
+        <p:blipFill>
+          <a:blip r:embed="rId3"/>
+          <a:stretch>
+            <a:fillRect/>
+          </a:stretch>
+        </p:blipFill>
+        <p:spPr>
+          <a:xfrm>
+            <a:off x="8439912" y="1737360"/>
+            <a:ext cx="3200400" cy="2000250"/>
+          </a:xfrm>
+          <a:prstGeom prst="rect">
+            <a:avLst/>
+          </a:prstGeom>
+          <a:ln w="9525">
+            <a:solidFill>
+              <a:srgbClr val="C3C2B7"/>
+            </a:solidFill>
+          </a:ln>
+        </p:spPr>
+      </p:pic>
+      <p:sp>
+        <p:nvSpPr>
+          <p:cNvPr id="17" name="Oval 16"/>
+          <p:cNvSpPr/>
+          <p:nvPr/>
+        </p:nvSpPr>
+        <p:spPr>
+          <a:xfrm>
+            <a:off x="8513064" y="1810512"/>
+            <a:ext cx="292608" cy="292608"/>
+          </a:xfrm>
+          <a:prstGeom prst="ellipse">
+            <a:avLst/>
+          </a:prstGeom>
+          <a:solidFill>
+            <a:srgbClr val="2A78D6"/>
+          </a:solidFill>
+          <a:ln>
+            <a:noFill/>
+          </a:ln>
+          <a:effectLst/>
+        </p:spPr>
+        <p:style>
+          <a:lnRef idx="1">
+            <a:schemeClr val="accent1"/>
+          </a:lnRef>
+          <a:fillRef idx="3">
+            <a:schemeClr val="accent1"/>
+          </a:fillRef>
+          <a:effectRef idx="2">
+            <a:schemeClr val="accent1"/>
+          </a:effectRef>
+          <a:fontRef idx="minor">
+            <a:schemeClr val="lt1"/>
+          </a:fontRef>
+        </p:style>
+        <p:txBody>
+          <a:bodyPr rtlCol="0" anchor="ctr" lIns="0" rIns="0"/>
+          <a:lstStyle/>
+          <a:p>
+            <a:pPr algn="ctr"/>
+            <a:r>
+              <a:rPr sz="1000" b="0" i="0">
+                <a:solidFill>
+                  <a:srgbClr val="FFFFFF"/>
+                </a:solidFill>
+                <a:latin typeface="Segoe UI Semibold"/>
+              </a:rPr>
+              <a:t>2</a:t>
+            </a:r>
+          </a:p>
+        </p:txBody>
+      </p:sp>
+      <p:pic>
+        <p:nvPicPr>
+          <p:cNvPr id="18" name="Picture 17" descr="3-integrity-audit.png"/>
+          <p:cNvPicPr>
+            <a:picLocks noChangeAspect="1"/>
+          </p:cNvPicPr>
+          <p:nvPr/>
+        </p:nvPicPr>
+        <p:blipFill>
+          <a:blip r:embed="rId4"/>
+          <a:stretch>
+            <a:fillRect/>
+          </a:stretch>
+        </p:blipFill>
+        <p:spPr>
+          <a:xfrm>
+            <a:off x="5074920" y="3902202"/>
+            <a:ext cx="3200400" cy="2000250"/>
+          </a:xfrm>
+          <a:prstGeom prst="rect">
+            <a:avLst/>
+          </a:prstGeom>
+          <a:ln w="9525">
+            <a:solidFill>
+              <a:srgbClr val="C3C2B7"/>
+            </a:solidFill>
+          </a:ln>
+        </p:spPr>
+      </p:pic>
+      <p:sp>
+        <p:nvSpPr>
+          <p:cNvPr id="19" name="Oval 18"/>
+          <p:cNvSpPr/>
+          <p:nvPr/>
+        </p:nvSpPr>
+        <p:spPr>
+          <a:xfrm>
+            <a:off x="5148072" y="3975354"/>
+            <a:ext cx="292608" cy="292608"/>
+          </a:xfrm>
+          <a:prstGeom prst="ellipse">
+            <a:avLst/>
+          </a:prstGeom>
+          <a:solidFill>
+            <a:srgbClr val="2A78D6"/>
+          </a:solidFill>
+          <a:ln>
+            <a:noFill/>
+          </a:ln>
+          <a:effectLst/>
+        </p:spPr>
+        <p:style>
+          <a:lnRef idx="1">
+            <a:schemeClr val="accent1"/>
+          </a:lnRef>
+          <a:fillRef idx="3">
+            <a:schemeClr val="accent1"/>
+          </a:fillRef>
+          <a:effectRef idx="2">
+            <a:schemeClr val="accent1"/>
+          </a:effectRef>
+          <a:fontRef idx="minor">
+            <a:schemeClr val="lt1"/>
+          </a:fontRef>
+        </p:style>
+        <p:txBody>
+          <a:bodyPr rtlCol="0" anchor="ctr" lIns="0" rIns="0"/>
+          <a:lstStyle/>
+          <a:p>
+            <a:pPr algn="ctr"/>
+            <a:r>
+              <a:rPr sz="1000" b="0" i="0">
+                <a:solidFill>
+                  <a:srgbClr val="FFFFFF"/>
+                </a:solidFill>
+                <a:latin typeface="Segoe UI Semibold"/>
+              </a:rPr>
+              <a:t>3</a:t>
+            </a:r>
+          </a:p>
+        </p:txBody>
+      </p:sp>
+      <p:pic>
+        <p:nvPicPr>
+          <p:cNvPr id="20" name="Picture 19" descr="4-system-transparency.png"/>
+          <p:cNvPicPr>
+            <a:picLocks noChangeAspect="1"/>
+          </p:cNvPicPr>
+          <p:nvPr/>
+        </p:nvPicPr>
+        <p:blipFill>
+          <a:blip r:embed="rId5"/>
+          <a:stretch>
+            <a:fillRect/>
+          </a:stretch>
+        </p:blipFill>
+        <p:spPr>
+          <a:xfrm>
+            <a:off x="8439912" y="3902202"/>
+            <a:ext cx="3200400" cy="2000250"/>
+          </a:xfrm>
+          <a:prstGeom prst="rect">
+            <a:avLst/>
+          </a:prstGeom>
+          <a:ln w="9525">
+            <a:solidFill>
+              <a:srgbClr val="C3C2B7"/>
+            </a:solidFill>
+          </a:ln>
+        </p:spPr>
+      </p:pic>
+      <p:sp>
+        <p:nvSpPr>
+          <p:cNvPr id="21" name="Oval 20"/>
+          <p:cNvSpPr/>
+          <p:nvPr/>
+        </p:nvSpPr>
+        <p:spPr>
+          <a:xfrm>
+            <a:off x="8513064" y="3975354"/>
+            <a:ext cx="292608" cy="292608"/>
+          </a:xfrm>
+          <a:prstGeom prst="ellipse">
+            <a:avLst/>
+          </a:prstGeom>
+          <a:solidFill>
+            <a:srgbClr val="2A78D6"/>
+          </a:solidFill>
+          <a:ln>
+            <a:noFill/>
+          </a:ln>
+          <a:effectLst/>
+        </p:spPr>
+        <p:style>
+          <a:lnRef idx="1">
+            <a:schemeClr val="accent1"/>
+          </a:lnRef>
+          <a:fillRef idx="3">
+            <a:schemeClr val="accent1"/>
+          </a:fillRef>
+          <a:effectRef idx="2">
+            <a:schemeClr val="accent1"/>
+          </a:effectRef>
+          <a:fontRef idx="minor">
+            <a:schemeClr val="lt1"/>
+          </a:fontRef>
+        </p:style>
+        <p:txBody>
+          <a:bodyPr rtlCol="0" anchor="ctr" lIns="0" rIns="0"/>
+          <a:lstStyle/>
+          <a:p>
+            <a:pPr algn="ctr"/>
+            <a:r>
+              <a:rPr sz="1000" b="0" i="0">
+                <a:solidFill>
+                  <a:srgbClr val="FFFFFF"/>
+                </a:solidFill>
+                <a:latin typeface="Segoe UI Semibold"/>
+              </a:rPr>
+              <a:t>4</a:t>
             </a:r>
           </a:p>
         </p:txBody>
@@ -7880,7 +8248,7 @@
                 </a:solidFill>
                 <a:latin typeface="Segoe UI"/>
               </a:rPr>
-              <a:t>Counts from the live database, not a mock-up</a:t>
+              <a:t>The full corpus as ingested and audited — not a mock-up</a:t>
             </a:r>
           </a:p>
         </p:txBody>

</xml_diff>